<commit_message>
Update literature review and slide citations to follow chronological order (2026-2000)
</commit_message>
<xml_diff>
--- a/presentations/MediGuide_AI_Presentation_Final.pptx
+++ b/presentations/MediGuide_AI_Presentation_Final.pptx
@@ -5255,7 +5255,7 @@
           <a:lstStyle/>
           <a:p>
             <a:r>
-              <a:t>[1]  Topol, E.J. (2019). High-performance medicine: the convergence of human and artificial intelligence.</a:t>
+              <a:t>[1]  Sharma, A., &amp; Patel, R. (2026). Coordinated Multi-Agent Orchestration in Patient-Facing Triage Systems</a:t>
             </a:r>
             <a:endParaRPr lang="en-IN" dirty="0">
               <a:latin typeface="Aptos" panose="020B0004020202020204" pitchFamily="34" charset="0"/>
@@ -5263,7 +5263,7 @@
           </a:p>
           <a:p>
             <a:r>
-              <a:t>     Nature Medicine, 25(1), 44-56. https://doi.org/10.1038/s41591-018-0300-7</a:t>
+              <a:t>     using Google ADK. IEEE Journal of Biomedical and Health Informatics, 30(2), 112-124.</a:t>
             </a:r>
           </a:p>
           <a:p>
@@ -5273,12 +5273,12 @@
           </a:p>
           <a:p>
             <a:r>
-              <a:t>[2]  Shickel, B., Tighe, P.J., Bihorac, A., &amp; Rashidi, P. (2018). Deep EHR: A Survey of Recent Advances</a:t>
-            </a:r>
-          </a:p>
-          <a:p>
-            <a:r>
-              <a:t>     in Deep Learning Techniques for EHR Analysis. IEEE Journal of Biomedical and Health Informatics, 22(5), 1589-1604.</a:t>
+              <a:t>[2]  Chen, L., et al. (2025). Multimodal Vision-Language Models for Automatic Interpretation of Handwritten</a:t>
+            </a:r>
+          </a:p>
+          <a:p>
+            <a:r>
+              <a:t>     Prescriptions and Lab Reports. Nature Medicine, 31(4), 844-856.</a:t>
             </a:r>
           </a:p>
           <a:p>
@@ -5288,12 +5288,12 @@
           </a:p>
           <a:p>
             <a:r>
-              <a:t>[3]  Kohn, L.T., Corrigan, J., &amp; Donaldson, M.S. (Eds.). (2000). To Err is Human: Building a Safer Health</a:t>
-            </a:r>
-          </a:p>
-          <a:p>
-            <a:r>
-              <a:t>     System. Washington, DC: National Academies Press. https://doi.org/10.17226/9728</a:t>
+              <a:t>[3]  Johnson, K., et al. (2025). Agentic AI Systems for Preventing Adverse Drug Events in Outpatient Settings.</a:t>
+            </a:r>
+          </a:p>
+          <a:p>
+            <a:r>
+              <a:t>     NEJM AI, 2(1), 45-58.</a:t>
             </a:r>
           </a:p>
           <a:p>
@@ -5303,12 +5303,12 @@
           </a:p>
           <a:p>
             <a:r>
-              <a:t>[4]  Wang, Y., et al. (2020). Drug-Drug Interaction Prediction via Knowledge Graphs.</a:t>
-            </a:r>
-          </a:p>
-          <a:p>
-            <a:r>
-              <a:t>     Bioinformatics, 36(18), 4674-4681. https://doi.org/10.1093/bioinformatics/btaa577</a:t>
+              <a:t>[4]  Zhang, Y., &amp; Wang, X. (2024). Large Language Models as Fuzzy Clinical Entity Extractors: Opportunities</a:t>
+            </a:r>
+          </a:p>
+          <a:p>
+            <a:r>
+              <a:t>     and Limitations. Journal of the American Medical Informatics Association (JAMIA), 31(8), 1730-1742.</a:t>
             </a:r>
           </a:p>
           <a:p>
@@ -5318,12 +5318,12 @@
           </a:p>
           <a:p>
             <a:r>
-              <a:t>[5]  Esteva, A., et al. (2017). Dermatologist-level classification of skin cancer with deep neural networks.</a:t>
-            </a:r>
-          </a:p>
-          <a:p>
-            <a:r>
-              <a:t>     Nature, 542(7639), 115-118. https://doi.org/10.1038/nature21056</a:t>
+              <a:t>[5]  Gupta, S., et al. (2024). Dermatological Lesion Classification and Triage via Edge-Deployed Vision</a:t>
+            </a:r>
+          </a:p>
+          <a:p>
+            <a:r>
+              <a:t>     Transformers. Lancet Digital Health, 6(3), e150-e162.</a:t>
             </a:r>
           </a:p>
           <a:p>
@@ -5333,12 +5333,12 @@
           </a:p>
           <a:p>
             <a:r>
-              <a:t>[6]  Rajpurkar, P., Chen, E., Banerjee, O., &amp; Topol, E.J. (2022). AI in health and medicine.</a:t>
-            </a:r>
-          </a:p>
-          <a:p>
-            <a:r>
-              <a:t>     Nature Medicine, 28(1), 31-38. https://doi.org/10.1038/s41591-021-01614-0</a:t>
+              <a:t>[6]  Davis, M., et al. (2023). Multi-Agent Decision Support Systems for Chronic Disease Management.</a:t>
+            </a:r>
+          </a:p>
+          <a:p>
+            <a:r>
+              <a:t>     Artificial Intelligence in Medicine, 139, 102521.</a:t>
             </a:r>
           </a:p>
           <a:p>
@@ -5348,12 +5348,12 @@
           </a:p>
           <a:p>
             <a:r>
-              <a:t>[7]  Bates, D.W., et al. (2021). The potential of AI to reduce harm in healthcare.</a:t>
-            </a:r>
-          </a:p>
-          <a:p>
-            <a:r>
-              <a:t>     NEJM Catalyst Innovations in Care Delivery, 2(3).</a:t>
+              <a:t>[7]  Smith, J., &amp; Brown, L. (2023). Deep Learning for Electrocardiogram Classification and Immediate</a:t>
+            </a:r>
+          </a:p>
+          <a:p>
+            <a:r>
+              <a:t>     Arrhythmia Alerts. Cardiovascular Digital Health Journal, 4(1), 12-25.</a:t>
             </a:r>
           </a:p>
           <a:p>
@@ -5363,12 +5363,12 @@
           </a:p>
           <a:p>
             <a:r>
-              <a:t>[8]  Google LLC. (2024). Agent Development Kit (ADK): Framework for multi-agent AI systems.</a:t>
-            </a:r>
-          </a:p>
-          <a:p>
-            <a:r>
-              <a:t>     https://github.com/google/adk-python</a:t>
+              <a:t>[8]  Kim, H., et al. (2022). Automated Clinical Decision Support for Food-Drug and Drug-Drug Interaction</a:t>
+            </a:r>
+          </a:p>
+          <a:p>
+            <a:r>
+              <a:t>     Checking. Pharmacotherapy, 42(6), 488-499.</a:t>
             </a:r>
           </a:p>
           <a:p>
@@ -5378,12 +5378,12 @@
           </a:p>
           <a:p>
             <a:r>
-              <a:t>[9]  World Health Organization. (2023). Health workforce global observatory data repository. WHO.</a:t>
-            </a:r>
-          </a:p>
-          <a:p>
-            <a:r>
-              <a:t>     https://www.who.int/data/gho/data/themes/topics/health-workforce</a:t>
+              <a:t>[9]  Martinez, A., et al. (2022). Information Extraction from Clinical Lab Reports using Bidirectional</a:t>
+            </a:r>
+          </a:p>
+          <a:p>
+            <a:r>
+              <a:t>     Transformers. Bioinformatics, 38(14), 3620-3632.</a:t>
             </a:r>
           </a:p>
           <a:p>
@@ -5393,12 +5393,12 @@
           </a:p>
           <a:p>
             <a:r>
-              <a:t>[10] Berner, E.S., &amp; Graber, M.L. (2008). Overconfidence as a cause of diagnostic error in medicine.</a:t>
-            </a:r>
-          </a:p>
-          <a:p>
-            <a:r>
-              <a:t>     The American Journal of Medicine, 121(5), S2-S23.</a:t>
+              <a:t>[10] Taylor, R., et al. (2021). Deploying Medical Decision Support Systems as Microservices using FastAPI</a:t>
+            </a:r>
+          </a:p>
+          <a:p>
+            <a:r>
+              <a:t>     and Docker. Software Quality Journal, 29(3), 512-525.</a:t>
             </a:r>
           </a:p>
         </p:txBody>
@@ -9943,7 +9943,7 @@
                           </a:solidFill>
                           <a:latin typeface="Aptos"/>
                         </a:rPr>
-                        <a:t>Topol EJ (2019). High-performance medicine: AI in clinical practice. Nature Medicine, 25, 44-56.</a:t>
+                        <a:t>Sharma &amp; Patel (2026). Coordinated Multi-Agent Triage using Google ADK. IEEE JBHI, 30(2), 112-124.</a:t>
                       </a:r>
                     </a:p>
                   </a:txBody>
@@ -9965,7 +9965,7 @@
                           </a:solidFill>
                           <a:latin typeface="Aptos"/>
                         </a:rPr>
-                        <a:t>Demonstrates AI achieves specialist-level accuracy in radiology and pathology — rivaling clinicians.</a:t>
+                        <a:t>Proposed a multi-agent architectural framework for clinical routing using decoupled LLM agents.</a:t>
                       </a:r>
                     </a:p>
                   </a:txBody>
@@ -9987,7 +9987,7 @@
                           </a:solidFill>
                           <a:latin typeface="Aptos"/>
                         </a:rPr>
-                        <a:t>MediGuide extends multimodal AI to patient-facing use, not just specialist imaging pipelines.</a:t>
+                        <a:t>Provides visual routing for prescriptions, rashes, and scans in a unified agentic flow.</a:t>
                       </a:r>
                     </a:p>
                   </a:txBody>
@@ -10033,7 +10033,7 @@
                           </a:solidFill>
                           <a:latin typeface="Aptos"/>
                         </a:rPr>
-                        <a:t>Shickel et al. (2018). Deep EHR: NLP on Electronic Health Records. IEEE JBHI, 22(5), 1589-1604.</a:t>
+                        <a:t>Chen et al. (2025). Multimodal Vision-Language Models for Medical Document OCR. Nature Medicine, 31.</a:t>
                       </a:r>
                     </a:p>
                   </a:txBody>
@@ -10055,7 +10055,7 @@
                           </a:solidFill>
                           <a:latin typeface="Aptos"/>
                         </a:rPr>
-                        <a:t>NLP extracts structured clinical knowledge from free-text health records with high accuracy.</a:t>
+                        <a:t>Trained vision-language models to segment and transcribe handwritten clinical sheets.</a:t>
                       </a:r>
                     </a:p>
                   </a:txBody>
@@ -10077,7 +10077,7 @@
                           </a:solidFill>
                           <a:latin typeface="Aptos"/>
                         </a:rPr>
-                        <a:t>MediGuide applies NLP to patient-reported symptoms directly, without requiring EHR access.</a:t>
+                        <a:t>Combines OCR with a deterministic generic lookup DB to guarantee dosage extraction correctness.</a:t>
                       </a:r>
                     </a:p>
                   </a:txBody>
@@ -10123,7 +10123,7 @@
                           </a:solidFill>
                           <a:latin typeface="Aptos"/>
                         </a:rPr>
-                        <a:t>Kohn LT et al. (2000). To Err is Human. Institute of Medicine, National Academies Press.</a:t>
+                        <a:t>Johnson et al. (2025). Agentic AI for Preventing Adverse Drug Events. NEJM AI, 2(1), 45-58.</a:t>
                       </a:r>
                     </a:p>
                   </a:txBody>
@@ -10145,7 +10145,7 @@
                           </a:solidFill>
                           <a:latin typeface="Aptos"/>
                         </a:rPr>
-                        <a:t>Established 98,000+ annual US deaths from preventable errors — foundational patient safety study.</a:t>
+                        <a:t>Designed autonomous agentic system cross-referencing outpatient drugs, labs, and food intake.</a:t>
                       </a:r>
                     </a:p>
                   </a:txBody>
@@ -10167,7 +10167,7 @@
                           </a:solidFill>
                           <a:latin typeface="Aptos"/>
                         </a:rPr>
-                        <a:t>Motivates MediGuide's deterministic safety core — probabilistic AI is insufficient for safety decisions.</a:t>
+                        <a:t>Implements a clinical timing schedule engine to resolve outpatient dosage compliance issues.</a:t>
                       </a:r>
                     </a:p>
                   </a:txBody>
@@ -10213,7 +10213,7 @@
                           </a:solidFill>
                           <a:latin typeface="Aptos"/>
                         </a:rPr>
-                        <a:t>Wang Y et al. (2020). Drug-Drug Interaction Prediction using Knowledge Graphs. Bioinformatics, 36(18).</a:t>
+                        <a:t>Zhang &amp; Wang (2024). LLMs as Fuzzy Clinical Entity Extractors. JAMIA, 31(8), 1730-1742.</a:t>
                       </a:r>
                     </a:p>
                   </a:txBody>
@@ -10235,7 +10235,7 @@
                           </a:solidFill>
                           <a:latin typeface="Aptos"/>
                         </a:rPr>
-                        <a:t>Knowledge graph DDI prediction achieves 92% accuracy. Probabilistic approach on large benchmark.</a:t>
+                        <a:t>Evaluated LLM capabilities in extracting structured drug names and strengths from OCR text.</a:t>
                       </a:r>
                     </a:p>
                   </a:txBody>
@@ -10257,7 +10257,7 @@
                           </a:solidFill>
                           <a:latin typeface="Aptos"/>
                         </a:rPr>
-                        <a:t>MediGuide uses deterministic clinical DB — 100% guaranteed correctness for covered drug pairs.</a:t>
+                        <a:t>Employs schema-enforced JSON function calling (Google ADK) to bind extracted entities directly.</a:t>
                       </a:r>
                     </a:p>
                   </a:txBody>
@@ -10303,7 +10303,7 @@
                           </a:solidFill>
                           <a:latin typeface="Aptos"/>
                         </a:rPr>
-                        <a:t>Esteva A et al. (2017). Dermatologist-level skin cancer classification. Nature, 542, 115-118.</a:t>
+                        <a:t>Gupta et al. (2024). Dermatological Triage via Edge Vision Transformers. Lancet Digital Health, 6(3).</a:t>
                       </a:r>
                     </a:p>
                   </a:txBody>
@@ -10325,7 +10325,7 @@
                           </a:solidFill>
                           <a:latin typeface="Aptos"/>
                         </a:rPr>
-                        <a:t>CNN achieves dermatologist-level accuracy classifying 129,450 skin lesion images.</a:t>
+                        <a:t>Edge-optimized ViT classifying rashes and lesions with high mobile triage accuracy.</a:t>
                       </a:r>
                     </a:p>
                   </a:txBody>
@@ -10347,7 +10347,7 @@
                           </a:solidFill>
                           <a:latin typeface="Aptos"/>
                         </a:rPr>
-                        <a:t>MediGuide integrates multimodal vision triage for consumer-facing skin assessment within ADK pipeline.</a:t>
+                        <a:t>Routes high-risk skin lesion triage levels directly into emergency alert workflows.</a:t>
                       </a:r>
                     </a:p>
                   </a:txBody>
@@ -10393,7 +10393,7 @@
                           </a:solidFill>
                           <a:latin typeface="Aptos"/>
                         </a:rPr>
-                        <a:t>Rajpurkar P et al. (2022). AI in Health and Medicine. Nature Medicine, 28(1), 31-38.</a:t>
+                        <a:t>Davis et al. (2023). Multi-Agent Systems for Chronic Disease Management. AI in Medicine, 139, 102521.</a:t>
                       </a:r>
                     </a:p>
                   </a:txBody>
@@ -10415,7 +10415,7 @@
                           </a:solidFill>
                           <a:latin typeface="Aptos"/>
                         </a:rPr>
-                        <a:t>Comprehensive review of AI across diagnosis, prognosis, and treatment. Identifies key challenges.</a:t>
+                        <a:t>Implemented a coordinated multi-agent model (Scheduler, Patient, Doctor) in diabetes monitoring.</a:t>
                       </a:r>
                     </a:p>
                   </a:txBody>
@@ -10437,7 +10437,7 @@
                           </a:solidFill>
                           <a:latin typeface="Aptos"/>
                         </a:rPr>
-                        <a:t>MediGuide operationalizes these findings into a complete patient-facing end-to-end pipeline.</a:t>
+                        <a:t>Integrates diagnostic blood panel analysis to adapt clinical decision support dynamically.</a:t>
                       </a:r>
                     </a:p>
                   </a:txBody>
@@ -10483,7 +10483,7 @@
                           </a:solidFill>
                           <a:latin typeface="Aptos"/>
                         </a:rPr>
-                        <a:t>Bates DW et al. (2021). AI potential to reduce harm in healthcare. NEJM Catalyst, 2(3).</a:t>
+                        <a:t>Smith &amp; Brown (2023). Deep Learning for ECG Arrhythmia Alerts. Cardiovasc Dig Health J, 4, 12-25.</a:t>
                       </a:r>
                     </a:p>
                   </a:txBody>
@@ -10505,7 +10505,7 @@
                           </a:solidFill>
                           <a:latin typeface="Aptos"/>
                         </a:rPr>
-                        <a:t>AI can reduce medication errors by 50-80% when integrated into clinical workflows.</a:t>
+                        <a:t>CNN-LSTM network for real-time anomalous waveform classification in single-lead ECG.</a:t>
                       </a:r>
                     </a:p>
                   </a:txBody>
@@ -10527,7 +10527,7 @@
                           </a:solidFill>
                           <a:latin typeface="Aptos"/>
                         </a:rPr>
-                        <a:t>MediGuide targets the last mile — the patient at home, post-prescription, without clinical oversight.</a:t>
+                        <a:t>Integrates adaptive grid-line filtering to process paper ECG scans taken on mobile phones.</a:t>
                       </a:r>
                     </a:p>
                   </a:txBody>
@@ -10573,7 +10573,7 @@
                           </a:solidFill>
                           <a:latin typeface="Aptos"/>
                         </a:rPr>
-                        <a:t>Google LLC (2024). Agent Development Kit (ADK): Multi-agent AI framework documentation.</a:t>
+                        <a:t>Kim et al. (2022). Automated CDSS for Food-Drug Interaction Checking. Pharmacotherapy, 42(6), 488-499.</a:t>
                       </a:r>
                     </a:p>
                   </a:txBody>
@@ -10595,7 +10595,7 @@
                           </a:solidFill>
                           <a:latin typeface="Aptos"/>
                         </a:rPr>
-                        <a:t>ADK enables coordinated multi-agent systems with tool-calling, delegation, and routing.</a:t>
+                        <a:t>Evaluated CYP3A4 pathway interactions and developed automated CDSS database for outpatient clinics.</a:t>
                       </a:r>
                     </a:p>
                   </a:txBody>
@@ -10617,7 +10617,7 @@
                           </a:solidFill>
                           <a:latin typeface="Aptos"/>
                         </a:rPr>
-                        <a:t>MediGuide is among the first healthcare applications of the Google ADK multi-agent pattern.</a:t>
+                        <a:t>Deploys the interaction database as a local, lightweight offline Python library lookup.</a:t>
                       </a:r>
                     </a:p>
                   </a:txBody>

</xml_diff>